<commit_message>
[FHIR-50553](https://jira.hl7.org/browse/FHIR-50553): Updated DTR specification diagram
</commit_message>
<xml_diff>
--- a/docs/Diagrams.pptx
+++ b/docs/Diagrams.pptx
@@ -6,6 +6,7 @@
   </p:sldMasterIdLst>
   <p:sldIdLst>
     <p:sldId id="257" r:id="rId2"/>
+    <p:sldId id="258" r:id="rId3"/>
   </p:sldIdLst>
   <p:sldSz cx="12192000" cy="6858000"/>
   <p:notesSz cx="6858000" cy="9144000"/>
@@ -104,6 +105,11 @@
       </a:defRPr>
     </a:lvl9pPr>
   </p:defaultTextStyle>
+  <p:extLst>
+    <p:ext uri="{EFAFB233-063F-42B5-8137-9DF3F51BA10A}">
+      <p15:sldGuideLst xmlns:p15="http://schemas.microsoft.com/office/powerpoint/2012/main"/>
+    </p:ext>
+  </p:extLst>
 </p:presentation>
 </file>
 
@@ -254,7 +260,7 @@
           <a:p>
             <a:fld id="{183AD561-A12A-44F3-8A8A-71F2BBA25CCF}" type="datetimeFigureOut">
               <a:rPr lang="en-US" smtClean="0"/>
-              <a:t>11/18/2024</a:t>
+              <a:t>7/14/2025</a:t>
             </a:fld>
             <a:endParaRPr lang="en-US"/>
           </a:p>
@@ -452,7 +458,7 @@
           <a:p>
             <a:fld id="{183AD561-A12A-44F3-8A8A-71F2BBA25CCF}" type="datetimeFigureOut">
               <a:rPr lang="en-US" smtClean="0"/>
-              <a:t>11/18/2024</a:t>
+              <a:t>7/14/2025</a:t>
             </a:fld>
             <a:endParaRPr lang="en-US"/>
           </a:p>
@@ -660,7 +666,7 @@
           <a:p>
             <a:fld id="{183AD561-A12A-44F3-8A8A-71F2BBA25CCF}" type="datetimeFigureOut">
               <a:rPr lang="en-US" smtClean="0"/>
-              <a:t>11/18/2024</a:t>
+              <a:t>7/14/2025</a:t>
             </a:fld>
             <a:endParaRPr lang="en-US"/>
           </a:p>
@@ -858,7 +864,7 @@
           <a:p>
             <a:fld id="{183AD561-A12A-44F3-8A8A-71F2BBA25CCF}" type="datetimeFigureOut">
               <a:rPr lang="en-US" smtClean="0"/>
-              <a:t>11/18/2024</a:t>
+              <a:t>7/14/2025</a:t>
             </a:fld>
             <a:endParaRPr lang="en-US"/>
           </a:p>
@@ -1133,7 +1139,7 @@
           <a:p>
             <a:fld id="{183AD561-A12A-44F3-8A8A-71F2BBA25CCF}" type="datetimeFigureOut">
               <a:rPr lang="en-US" smtClean="0"/>
-              <a:t>11/18/2024</a:t>
+              <a:t>7/14/2025</a:t>
             </a:fld>
             <a:endParaRPr lang="en-US"/>
           </a:p>
@@ -1398,7 +1404,7 @@
           <a:p>
             <a:fld id="{183AD561-A12A-44F3-8A8A-71F2BBA25CCF}" type="datetimeFigureOut">
               <a:rPr lang="en-US" smtClean="0"/>
-              <a:t>11/18/2024</a:t>
+              <a:t>7/14/2025</a:t>
             </a:fld>
             <a:endParaRPr lang="en-US"/>
           </a:p>
@@ -1810,7 +1816,7 @@
           <a:p>
             <a:fld id="{183AD561-A12A-44F3-8A8A-71F2BBA25CCF}" type="datetimeFigureOut">
               <a:rPr lang="en-US" smtClean="0"/>
-              <a:t>11/18/2024</a:t>
+              <a:t>7/14/2025</a:t>
             </a:fld>
             <a:endParaRPr lang="en-US"/>
           </a:p>
@@ -1951,7 +1957,7 @@
           <a:p>
             <a:fld id="{183AD561-A12A-44F3-8A8A-71F2BBA25CCF}" type="datetimeFigureOut">
               <a:rPr lang="en-US" smtClean="0"/>
-              <a:t>11/18/2024</a:t>
+              <a:t>7/14/2025</a:t>
             </a:fld>
             <a:endParaRPr lang="en-US"/>
           </a:p>
@@ -2064,7 +2070,7 @@
           <a:p>
             <a:fld id="{183AD561-A12A-44F3-8A8A-71F2BBA25CCF}" type="datetimeFigureOut">
               <a:rPr lang="en-US" smtClean="0"/>
-              <a:t>11/18/2024</a:t>
+              <a:t>7/14/2025</a:t>
             </a:fld>
             <a:endParaRPr lang="en-US"/>
           </a:p>
@@ -2375,7 +2381,7 @@
           <a:p>
             <a:fld id="{183AD561-A12A-44F3-8A8A-71F2BBA25CCF}" type="datetimeFigureOut">
               <a:rPr lang="en-US" smtClean="0"/>
-              <a:t>11/18/2024</a:t>
+              <a:t>7/14/2025</a:t>
             </a:fld>
             <a:endParaRPr lang="en-US"/>
           </a:p>
@@ -2663,7 +2669,7 @@
           <a:p>
             <a:fld id="{183AD561-A12A-44F3-8A8A-71F2BBA25CCF}" type="datetimeFigureOut">
               <a:rPr lang="en-US" smtClean="0"/>
-              <a:t>11/18/2024</a:t>
+              <a:t>7/14/2025</a:t>
             </a:fld>
             <a:endParaRPr lang="en-US"/>
           </a:p>
@@ -2904,7 +2910,7 @@
           <a:p>
             <a:fld id="{183AD561-A12A-44F3-8A8A-71F2BBA25CCF}" type="datetimeFigureOut">
               <a:rPr lang="en-US" smtClean="0"/>
-              <a:t>11/18/2024</a:t>
+              <a:t>7/14/2025</a:t>
             </a:fld>
             <a:endParaRPr lang="en-US"/>
           </a:p>
@@ -3684,6 +3690,487 @@
 </p:sld>
 </file>
 
+<file path=ppt/slides/slide2.xml><?xml version="1.0" encoding="utf-8"?>
+<p:sld xmlns:a="http://schemas.openxmlformats.org/drawingml/2006/main" xmlns:r="http://schemas.openxmlformats.org/officeDocument/2006/relationships" xmlns:p="http://schemas.openxmlformats.org/presentationml/2006/main">
+  <p:cSld>
+    <p:spTree>
+      <p:nvGrpSpPr>
+        <p:cNvPr id="1" name=""/>
+        <p:cNvGrpSpPr/>
+        <p:nvPr/>
+      </p:nvGrpSpPr>
+      <p:grpSpPr>
+        <a:xfrm>
+          <a:off x="0" y="0"/>
+          <a:ext cx="0" cy="0"/>
+          <a:chOff x="0" y="0"/>
+          <a:chExt cx="0" cy="0"/>
+        </a:xfrm>
+      </p:grpSpPr>
+      <p:pic>
+        <p:nvPicPr>
+          <p:cNvPr id="1026" name="Picture 2" descr="DTRQuestionnairePackageOperation">
+            <a:extLst>
+              <a:ext uri="{FF2B5EF4-FFF2-40B4-BE49-F238E27FC236}">
+                <a16:creationId xmlns:a16="http://schemas.microsoft.com/office/drawing/2014/main" id="{9D38BF5F-6F06-595D-C264-6AAB9C1F3567}"/>
+              </a:ext>
+            </a:extLst>
+          </p:cNvPr>
+          <p:cNvPicPr>
+            <a:picLocks noChangeAspect="1" noChangeArrowheads="1"/>
+          </p:cNvPicPr>
+          <p:nvPr/>
+        </p:nvPicPr>
+        <p:blipFill>
+          <a:blip r:embed="rId2">
+            <a:extLst>
+              <a:ext uri="{28A0092B-C50C-407E-A947-70E740481C1C}">
+                <a14:useLocalDpi xmlns:a14="http://schemas.microsoft.com/office/drawing/2010/main" val="0"/>
+              </a:ext>
+            </a:extLst>
+          </a:blip>
+          <a:srcRect/>
+          <a:stretch>
+            <a:fillRect/>
+          </a:stretch>
+        </p:blipFill>
+        <p:spPr bwMode="auto">
+          <a:xfrm>
+            <a:off x="1081088" y="276225"/>
+            <a:ext cx="10029825" cy="6305550"/>
+          </a:xfrm>
+          <a:prstGeom prst="rect">
+            <a:avLst/>
+          </a:prstGeom>
+          <a:noFill/>
+          <a:extLst>
+            <a:ext uri="{909E8E84-426E-40DD-AFC4-6F175D3DCCD1}">
+              <a14:hiddenFill xmlns:a14="http://schemas.microsoft.com/office/drawing/2010/main">
+                <a:solidFill>
+                  <a:srgbClr val="FFFFFF"/>
+                </a:solidFill>
+              </a14:hiddenFill>
+            </a:ext>
+          </a:extLst>
+        </p:spPr>
+      </p:pic>
+      <p:sp>
+        <p:nvSpPr>
+          <p:cNvPr id="2" name="Rectangle: Rounded Corners 1">
+            <a:extLst>
+              <a:ext uri="{FF2B5EF4-FFF2-40B4-BE49-F238E27FC236}">
+                <a16:creationId xmlns:a16="http://schemas.microsoft.com/office/drawing/2014/main" id="{B28A7F6D-15D7-F7AE-241B-B6D921090043}"/>
+              </a:ext>
+            </a:extLst>
+          </p:cNvPr>
+          <p:cNvSpPr/>
+          <p:nvPr/>
+        </p:nvSpPr>
+        <p:spPr>
+          <a:xfrm>
+            <a:off x="5661213" y="3368490"/>
+            <a:ext cx="2736476" cy="282388"/>
+          </a:xfrm>
+          <a:prstGeom prst="roundRect">
+            <a:avLst/>
+          </a:prstGeom>
+          <a:noFill/>
+          <a:ln w="38100">
+            <a:solidFill>
+              <a:schemeClr val="accent6"/>
+            </a:solidFill>
+          </a:ln>
+        </p:spPr>
+        <p:style>
+          <a:lnRef idx="2">
+            <a:schemeClr val="accent1">
+              <a:shade val="15000"/>
+            </a:schemeClr>
+          </a:lnRef>
+          <a:fillRef idx="1">
+            <a:schemeClr val="accent1"/>
+          </a:fillRef>
+          <a:effectRef idx="0">
+            <a:schemeClr val="accent1"/>
+          </a:effectRef>
+          <a:fontRef idx="minor">
+            <a:schemeClr val="lt1"/>
+          </a:fontRef>
+        </p:style>
+        <p:txBody>
+          <a:bodyPr rtlCol="0" anchor="ctr"/>
+          <a:lstStyle/>
+          <a:p>
+            <a:pPr algn="ctr"/>
+            <a:endParaRPr lang="en-US"/>
+          </a:p>
+        </p:txBody>
+      </p:sp>
+      <p:sp>
+        <p:nvSpPr>
+          <p:cNvPr id="3" name="Oval 2">
+            <a:extLst>
+              <a:ext uri="{FF2B5EF4-FFF2-40B4-BE49-F238E27FC236}">
+                <a16:creationId xmlns:a16="http://schemas.microsoft.com/office/drawing/2014/main" id="{DA053EF4-46CE-D58B-A460-54348559665F}"/>
+              </a:ext>
+            </a:extLst>
+          </p:cNvPr>
+          <p:cNvSpPr/>
+          <p:nvPr/>
+        </p:nvSpPr>
+        <p:spPr>
+          <a:xfrm>
+            <a:off x="5505685" y="3368490"/>
+            <a:ext cx="311056" cy="282388"/>
+          </a:xfrm>
+          <a:prstGeom prst="ellipse">
+            <a:avLst/>
+          </a:prstGeom>
+        </p:spPr>
+        <p:style>
+          <a:lnRef idx="2">
+            <a:schemeClr val="accent1">
+              <a:shade val="15000"/>
+            </a:schemeClr>
+          </a:lnRef>
+          <a:fillRef idx="1">
+            <a:schemeClr val="accent1"/>
+          </a:fillRef>
+          <a:effectRef idx="0">
+            <a:schemeClr val="accent1"/>
+          </a:effectRef>
+          <a:fontRef idx="minor">
+            <a:schemeClr val="lt1"/>
+          </a:fontRef>
+        </p:style>
+        <p:txBody>
+          <a:bodyPr rtlCol="0" anchor="ctr"/>
+          <a:lstStyle/>
+          <a:p>
+            <a:pPr algn="ctr"/>
+            <a:r>
+              <a:rPr lang="en-US" dirty="0"/>
+              <a:t>1</a:t>
+            </a:r>
+          </a:p>
+        </p:txBody>
+      </p:sp>
+      <p:sp>
+        <p:nvSpPr>
+          <p:cNvPr id="5" name="Rectangle: Rounded Corners 4">
+            <a:extLst>
+              <a:ext uri="{FF2B5EF4-FFF2-40B4-BE49-F238E27FC236}">
+                <a16:creationId xmlns:a16="http://schemas.microsoft.com/office/drawing/2014/main" id="{49ED3269-1EE9-10DC-BC29-BCEF32178462}"/>
+              </a:ext>
+            </a:extLst>
+          </p:cNvPr>
+          <p:cNvSpPr/>
+          <p:nvPr/>
+        </p:nvSpPr>
+        <p:spPr>
+          <a:xfrm>
+            <a:off x="3408829" y="3904128"/>
+            <a:ext cx="2096856" cy="282388"/>
+          </a:xfrm>
+          <a:prstGeom prst="roundRect">
+            <a:avLst/>
+          </a:prstGeom>
+          <a:noFill/>
+          <a:ln w="38100">
+            <a:solidFill>
+              <a:schemeClr val="accent6"/>
+            </a:solidFill>
+          </a:ln>
+        </p:spPr>
+        <p:style>
+          <a:lnRef idx="2">
+            <a:schemeClr val="accent1">
+              <a:shade val="15000"/>
+            </a:schemeClr>
+          </a:lnRef>
+          <a:fillRef idx="1">
+            <a:schemeClr val="accent1"/>
+          </a:fillRef>
+          <a:effectRef idx="0">
+            <a:schemeClr val="accent1"/>
+          </a:effectRef>
+          <a:fontRef idx="minor">
+            <a:schemeClr val="lt1"/>
+          </a:fontRef>
+        </p:style>
+        <p:txBody>
+          <a:bodyPr rtlCol="0" anchor="ctr"/>
+          <a:lstStyle/>
+          <a:p>
+            <a:pPr algn="ctr"/>
+            <a:endParaRPr lang="en-US"/>
+          </a:p>
+        </p:txBody>
+      </p:sp>
+      <p:sp>
+        <p:nvSpPr>
+          <p:cNvPr id="6" name="Oval 5">
+            <a:extLst>
+              <a:ext uri="{FF2B5EF4-FFF2-40B4-BE49-F238E27FC236}">
+                <a16:creationId xmlns:a16="http://schemas.microsoft.com/office/drawing/2014/main" id="{D09496E4-F150-6AD4-3017-1B955BA91095}"/>
+              </a:ext>
+            </a:extLst>
+          </p:cNvPr>
+          <p:cNvSpPr/>
+          <p:nvPr/>
+        </p:nvSpPr>
+        <p:spPr>
+          <a:xfrm>
+            <a:off x="5397222" y="3904128"/>
+            <a:ext cx="311056" cy="282388"/>
+          </a:xfrm>
+          <a:prstGeom prst="ellipse">
+            <a:avLst/>
+          </a:prstGeom>
+        </p:spPr>
+        <p:style>
+          <a:lnRef idx="2">
+            <a:schemeClr val="accent1">
+              <a:shade val="15000"/>
+            </a:schemeClr>
+          </a:lnRef>
+          <a:fillRef idx="1">
+            <a:schemeClr val="accent1"/>
+          </a:fillRef>
+          <a:effectRef idx="0">
+            <a:schemeClr val="accent1"/>
+          </a:effectRef>
+          <a:fontRef idx="minor">
+            <a:schemeClr val="lt1"/>
+          </a:fontRef>
+        </p:style>
+        <p:txBody>
+          <a:bodyPr rtlCol="0" anchor="ctr"/>
+          <a:lstStyle/>
+          <a:p>
+            <a:pPr algn="ctr"/>
+            <a:r>
+              <a:rPr lang="en-US" dirty="0"/>
+              <a:t>2</a:t>
+            </a:r>
+          </a:p>
+        </p:txBody>
+      </p:sp>
+      <p:sp>
+        <p:nvSpPr>
+          <p:cNvPr id="9" name="Rectangle: Rounded Corners 8">
+            <a:extLst>
+              <a:ext uri="{FF2B5EF4-FFF2-40B4-BE49-F238E27FC236}">
+                <a16:creationId xmlns:a16="http://schemas.microsoft.com/office/drawing/2014/main" id="{4B3FC616-A004-3B88-9A60-C059A2FA4D02}"/>
+              </a:ext>
+            </a:extLst>
+          </p:cNvPr>
+          <p:cNvSpPr/>
+          <p:nvPr/>
+        </p:nvSpPr>
+        <p:spPr>
+          <a:xfrm>
+            <a:off x="5295014" y="4524935"/>
+            <a:ext cx="3388660" cy="894229"/>
+          </a:xfrm>
+          <a:prstGeom prst="roundRect">
+            <a:avLst/>
+          </a:prstGeom>
+          <a:noFill/>
+          <a:ln w="38100">
+            <a:solidFill>
+              <a:schemeClr val="accent6"/>
+            </a:solidFill>
+          </a:ln>
+        </p:spPr>
+        <p:style>
+          <a:lnRef idx="2">
+            <a:schemeClr val="accent1">
+              <a:shade val="15000"/>
+            </a:schemeClr>
+          </a:lnRef>
+          <a:fillRef idx="1">
+            <a:schemeClr val="accent1"/>
+          </a:fillRef>
+          <a:effectRef idx="0">
+            <a:schemeClr val="accent1"/>
+          </a:effectRef>
+          <a:fontRef idx="minor">
+            <a:schemeClr val="lt1"/>
+          </a:fontRef>
+        </p:style>
+        <p:txBody>
+          <a:bodyPr rtlCol="0" anchor="ctr"/>
+          <a:lstStyle/>
+          <a:p>
+            <a:pPr algn="ctr"/>
+            <a:endParaRPr lang="en-US"/>
+          </a:p>
+        </p:txBody>
+      </p:sp>
+      <p:sp>
+        <p:nvSpPr>
+          <p:cNvPr id="10" name="Oval 9">
+            <a:extLst>
+              <a:ext uri="{FF2B5EF4-FFF2-40B4-BE49-F238E27FC236}">
+                <a16:creationId xmlns:a16="http://schemas.microsoft.com/office/drawing/2014/main" id="{CBFC6C4D-24E4-18DD-8338-A6979E40EE86}"/>
+              </a:ext>
+            </a:extLst>
+          </p:cNvPr>
+          <p:cNvSpPr/>
+          <p:nvPr/>
+        </p:nvSpPr>
+        <p:spPr>
+          <a:xfrm>
+            <a:off x="8528146" y="4830855"/>
+            <a:ext cx="311056" cy="282388"/>
+          </a:xfrm>
+          <a:prstGeom prst="ellipse">
+            <a:avLst/>
+          </a:prstGeom>
+        </p:spPr>
+        <p:style>
+          <a:lnRef idx="2">
+            <a:schemeClr val="accent1">
+              <a:shade val="15000"/>
+            </a:schemeClr>
+          </a:lnRef>
+          <a:fillRef idx="1">
+            <a:schemeClr val="accent1"/>
+          </a:fillRef>
+          <a:effectRef idx="0">
+            <a:schemeClr val="accent1"/>
+          </a:effectRef>
+          <a:fontRef idx="minor">
+            <a:schemeClr val="lt1"/>
+          </a:fontRef>
+        </p:style>
+        <p:txBody>
+          <a:bodyPr rtlCol="0" anchor="ctr"/>
+          <a:lstStyle/>
+          <a:p>
+            <a:pPr algn="ctr"/>
+            <a:r>
+              <a:rPr lang="en-US" dirty="0"/>
+              <a:t>4</a:t>
+            </a:r>
+          </a:p>
+        </p:txBody>
+      </p:sp>
+      <p:sp>
+        <p:nvSpPr>
+          <p:cNvPr id="7" name="Rectangle: Rounded Corners 6">
+            <a:extLst>
+              <a:ext uri="{FF2B5EF4-FFF2-40B4-BE49-F238E27FC236}">
+                <a16:creationId xmlns:a16="http://schemas.microsoft.com/office/drawing/2014/main" id="{D3E78AA1-91E5-05FC-975C-F6E8A00A5C1E}"/>
+              </a:ext>
+            </a:extLst>
+          </p:cNvPr>
+          <p:cNvSpPr/>
+          <p:nvPr/>
+        </p:nvSpPr>
+        <p:spPr>
+          <a:xfrm>
+            <a:off x="2164090" y="4356842"/>
+            <a:ext cx="3388660" cy="282389"/>
+          </a:xfrm>
+          <a:prstGeom prst="roundRect">
+            <a:avLst/>
+          </a:prstGeom>
+          <a:noFill/>
+          <a:ln w="38100">
+            <a:solidFill>
+              <a:schemeClr val="accent6"/>
+            </a:solidFill>
+          </a:ln>
+        </p:spPr>
+        <p:style>
+          <a:lnRef idx="2">
+            <a:schemeClr val="accent1">
+              <a:shade val="15000"/>
+            </a:schemeClr>
+          </a:lnRef>
+          <a:fillRef idx="1">
+            <a:schemeClr val="accent1"/>
+          </a:fillRef>
+          <a:effectRef idx="0">
+            <a:schemeClr val="accent1"/>
+          </a:effectRef>
+          <a:fontRef idx="minor">
+            <a:schemeClr val="lt1"/>
+          </a:fontRef>
+        </p:style>
+        <p:txBody>
+          <a:bodyPr rtlCol="0" anchor="ctr"/>
+          <a:lstStyle/>
+          <a:p>
+            <a:pPr algn="ctr"/>
+            <a:endParaRPr lang="en-US"/>
+          </a:p>
+        </p:txBody>
+      </p:sp>
+      <p:sp>
+        <p:nvSpPr>
+          <p:cNvPr id="8" name="Oval 7">
+            <a:extLst>
+              <a:ext uri="{FF2B5EF4-FFF2-40B4-BE49-F238E27FC236}">
+                <a16:creationId xmlns:a16="http://schemas.microsoft.com/office/drawing/2014/main" id="{4B75150F-B61F-A3C5-D081-63DE3DE8E8C1}"/>
+              </a:ext>
+            </a:extLst>
+          </p:cNvPr>
+          <p:cNvSpPr/>
+          <p:nvPr/>
+        </p:nvSpPr>
+        <p:spPr>
+          <a:xfrm>
+            <a:off x="5397222" y="4356843"/>
+            <a:ext cx="311056" cy="282388"/>
+          </a:xfrm>
+          <a:prstGeom prst="ellipse">
+            <a:avLst/>
+          </a:prstGeom>
+        </p:spPr>
+        <p:style>
+          <a:lnRef idx="2">
+            <a:schemeClr val="accent1">
+              <a:shade val="15000"/>
+            </a:schemeClr>
+          </a:lnRef>
+          <a:fillRef idx="1">
+            <a:schemeClr val="accent1"/>
+          </a:fillRef>
+          <a:effectRef idx="0">
+            <a:schemeClr val="accent1"/>
+          </a:effectRef>
+          <a:fontRef idx="minor">
+            <a:schemeClr val="lt1"/>
+          </a:fontRef>
+        </p:style>
+        <p:txBody>
+          <a:bodyPr rtlCol="0" anchor="ctr"/>
+          <a:lstStyle/>
+          <a:p>
+            <a:pPr algn="ctr"/>
+            <a:r>
+              <a:rPr lang="en-US" dirty="0"/>
+              <a:t>3</a:t>
+            </a:r>
+          </a:p>
+        </p:txBody>
+      </p:sp>
+    </p:spTree>
+    <p:extLst>
+      <p:ext uri="{BB962C8B-B14F-4D97-AF65-F5344CB8AC3E}">
+        <p14:creationId xmlns:p14="http://schemas.microsoft.com/office/powerpoint/2010/main" val="3767590953"/>
+      </p:ext>
+    </p:extLst>
+  </p:cSld>
+  <p:clrMapOvr>
+    <a:masterClrMapping/>
+  </p:clrMapOvr>
+</p:sld>
+</file>
+
 <file path=ppt/theme/theme1.xml><?xml version="1.0" encoding="utf-8"?>
 <a:theme xmlns:a="http://schemas.openxmlformats.org/drawingml/2006/main" name="Office Theme">
   <a:themeElements>

</xml_diff>